<commit_message>
Add DEMO LEVEL test, DEMO_0002 analysis, and balanced-demo slide
- DEMO LEVEL command: same leveling as DEMO SPIN, then hold level at the
  start heading with no spin, no level timeout and no wheel bias, until
  STOP / KILL / wheel limit. New phase 'K' once level is reached; reports
  the armed and level-held times on STOP or the wheel limit.
- test_runs/DEMO_0002.CSV: six DEMO SPIN attempts after the balance
  weights. All stayed in Level and stopped at the 55 rad/s wheel-A limit:
  roll settled at ~2 deg (resting roll still ~3.3 deg, -y side heavy).
  Weights balanced pitch and slowed the free swing 1.8 -> 3.3 s.
- Prelim deck: new slide "Data: DEMO SPIN After Balancing" with
  Reports/figures/fig6_demo2_balanced.png; Future Plans updated.
- CLAUDE.md, TODO.md, PROGRESS_LOG.md updated.

Co-Authored-By: Claude Opus 5.5 <noreply@anthropic.com>
</commit_message>
<xml_diff>
--- a/Reports/Astro 331 Lab 8_2_3 Body Problem_Prelim_Pres_FILLED.pptx
+++ b/Reports/Astro 331 Lab 8_2_3 Body Problem_Prelim_Pres_FILLED.pptx
@@ -21,9 +21,10 @@
     <p:sldId id="267" r:id="rId21"/>
     <p:sldId id="268" r:id="rId22"/>
     <p:sldId id="269" r:id="rId23"/>
+    <p:sldId id="270" r:id="rId24"/>
     <p:sldId id="262" r:id="rId11"/>
-    <p:sldId id="270" r:id="rId24"/>
     <p:sldId id="271" r:id="rId25"/>
+    <p:sldId id="272" r:id="rId26"/>
   </p:sldIdLst>
   <p:sldSz cy="6858000" cx="9144000"/>
   <p:notesSz cx="6858000" cy="9144000"/>
@@ -16079,6 +16080,232 @@
           <a:lstStyle/>
           <a:p>
             <a:r>
+              <a:t>Data: DEMO SPIN After Balancing</a:t>
+            </a:r>
+          </a:p>
+        </p:txBody>
+      </p:sp>
+      <p:sp>
+        <p:nvSpPr>
+          <p:cNvPr id="91" name="Google Shape;91;p3"/>
+          <p:cNvSpPr txBox="1"/>
+          <p:nvPr>
+            <p:ph idx="12" type="sldNum"/>
+          </p:nvPr>
+        </p:nvSpPr>
+        <p:spPr>
+          <a:xfrm>
+            <a:off x="7040236" y="6465106"/>
+            <a:ext cx="2057400" cy="365125"/>
+          </a:xfrm>
+          <a:prstGeom prst="rect">
+            <a:avLst/>
+          </a:prstGeom>
+          <a:noFill/>
+          <a:ln>
+            <a:noFill/>
+          </a:ln>
+        </p:spPr>
+        <p:txBody>
+          <a:bodyPr anchorCtr="0" anchor="ctr" bIns="45700" lIns="91425" spcFirstLastPara="1" rIns="91425" wrap="square" tIns="45700">
+            <a:noAutofit/>
+          </a:bodyPr>
+          <a:lstStyle/>
+          <a:p>
+            <a:pPr indent="0" lvl="0" marL="0" rtl="0" algn="r">
+              <a:lnSpc>
+                <a:spcPct val="100000"/>
+              </a:lnSpc>
+              <a:spcBef>
+                <a:spcPts val="0"/>
+              </a:spcBef>
+              <a:spcAft>
+                <a:spcPts val="0"/>
+              </a:spcAft>
+              <a:buSzPts val="1200"/>
+              <a:buNone/>
+            </a:pPr>
+            <a:fld id="{00000000-1234-1234-1234-123412341234}" type="slidenum">
+              <a:rPr lang="en-US"/>
+              <a:t>‹#›</a:t>
+            </a:fld>
+            <a:endParaRPr/>
+          </a:p>
+        </p:txBody>
+      </p:sp>
+      <p:pic>
+        <p:nvPicPr>
+          <p:cNvPr id="92" name="Picture 91" descr="fig6_demo2_balanced.png"/>
+          <p:cNvPicPr>
+            <a:picLocks noChangeAspect="1"/>
+          </p:cNvPicPr>
+          <p:nvPr/>
+        </p:nvPicPr>
+        <p:blipFill>
+          <a:blip r:embed="rId2"/>
+          <a:stretch>
+            <a:fillRect/>
+          </a:stretch>
+        </p:blipFill>
+        <p:spPr>
+          <a:xfrm>
+            <a:off x="822960" y="896112"/>
+            <a:ext cx="7498079" cy="3488219"/>
+          </a:xfrm>
+          <a:prstGeom prst="rect">
+            <a:avLst/>
+          </a:prstGeom>
+        </p:spPr>
+      </p:pic>
+      <p:sp>
+        <p:nvSpPr>
+          <p:cNvPr id="93" name="TextBox 92"/>
+          <p:cNvSpPr txBox="1"/>
+          <p:nvPr/>
+        </p:nvSpPr>
+        <p:spPr>
+          <a:xfrm>
+            <a:off x="274320" y="4434840"/>
+            <a:ext cx="8595360" cy="2011680"/>
+          </a:xfrm>
+          <a:prstGeom prst="rect">
+            <a:avLst/>
+          </a:prstGeom>
+          <a:noFill/>
+        </p:spPr>
+        <p:txBody>
+          <a:bodyPr wrap="square" lIns="73152" rIns="73152">
+            <a:spAutoFit/>
+          </a:bodyPr>
+          <a:lstStyle/>
+          <a:p>
+            <a:pPr marL="0" indent="0">
+              <a:lnSpc>
+                <a:spcPct val="95000"/>
+              </a:lnSpc>
+              <a:spcBef>
+                <a:spcPts val="300"/>
+              </a:spcBef>
+              <a:buNone/>
+            </a:pPr>
+            <a:r>
+              <a:rPr b="1" sz="1300">
+                <a:latin typeface="Quattrocento Sans"/>
+              </a:rPr>
+              <a:t>MEASURE:  </a:t>
+            </a:r>
+            <a:r>
+              <a:rPr sz="1300" b="0">
+                <a:latin typeface="Quattrocento Sans"/>
+              </a:rPr>
+              <a:t>Six DEMO SPIN attempts after adding balance weights: roll, wheel speeds, and the free swing.</a:t>
+            </a:r>
+          </a:p>
+          <a:p>
+            <a:pPr marL="0" indent="0">
+              <a:lnSpc>
+                <a:spcPct val="95000"/>
+              </a:lnSpc>
+              <a:spcBef>
+                <a:spcPts val="300"/>
+              </a:spcBef>
+              <a:buNone/>
+            </a:pPr>
+            <a:r>
+              <a:rPr b="1" sz="1300">
+                <a:latin typeface="Quattrocento Sans"/>
+              </a:rPr>
+              <a:t>COMPARE:  </a:t>
+            </a:r>
+            <a:r>
+              <a:rPr sz="1300" b="0">
+                <a:latin typeface="Quattrocento Sans"/>
+              </a:rPr>
+              <a:t>Expected: level (&lt; 1° for 3 s), then spin. Instead every attempt stayed in Level and stopped at the 55 rad/s wheel limit after 2.2–3.7 s (1–2 s before the weights).</a:t>
+            </a:r>
+          </a:p>
+          <a:p>
+            <a:pPr marL="0" indent="0">
+              <a:lnSpc>
+                <a:spcPct val="95000"/>
+              </a:lnSpc>
+              <a:spcBef>
+                <a:spcPts val="300"/>
+              </a:spcBef>
+              <a:buNone/>
+            </a:pPr>
+            <a:r>
+              <a:rPr b="1" sz="1300">
+                <a:latin typeface="Quattrocento Sans"/>
+              </a:rPr>
+              <a:t>EXPLAIN:  </a:t>
+            </a:r>
+            <a:r>
+              <a:rPr sz="1300" b="0">
+                <a:latin typeface="Quattrocento Sans"/>
+              </a:rPr>
+              <a:t>Weights cut gravity’s pull ≈3× (swing period 1.8 → 3.3 s) and balanced pitch, but roll still rests ≈3.3° off level (−y side heavy). Holding roll at ≈2° pushes ≈8 mN·m against gravity and fills wheel A in ≈3 s; the stop then brakes the wheels and kicks the table.</a:t>
+            </a:r>
+          </a:p>
+          <a:p>
+            <a:pPr marL="0" indent="0">
+              <a:lnSpc>
+                <a:spcPct val="95000"/>
+              </a:lnSpc>
+              <a:spcBef>
+                <a:spcPts val="300"/>
+              </a:spcBef>
+              <a:buNone/>
+            </a:pPr>
+            <a:r>
+              <a:rPr b="1" sz="1300">
+                <a:latin typeface="Quattrocento Sans"/>
+              </a:rPr>
+              <a:t>NEXT:  </a:t>
+            </a:r>
+            <a:r>
+              <a:rPr sz="1300" b="0">
+                <a:latin typeface="Quattrocento Sans"/>
+              </a:rPr>
+              <a:t>Trim roll (weight toward +y, ≈15 mN·m); new DEMO LEVEL test (level + hold, no spin) to measure hold time; ramp the wheels down instead of braking.</a:t>
+            </a:r>
+          </a:p>
+        </p:txBody>
+      </p:sp>
+    </p:spTree>
+  </p:cSld>
+  <p:clrMapOvr>
+    <a:masterClrMapping/>
+  </p:clrMapOvr>
+</p:sld>
+</file>
+
+<file path=ppt/slides/slide16.xml><?xml version="1.0" encoding="utf-8"?>
+<p:sld xmlns:a="http://schemas.openxmlformats.org/drawingml/2006/main" xmlns:p="http://schemas.openxmlformats.org/presentationml/2006/main" xmlns:r="http://schemas.openxmlformats.org/officeDocument/2006/relationships">
+  <p:cSld>
+    <p:spTree>
+      <p:nvGrpSpPr>
+        <p:cNvPr id="1" name=""/>
+        <p:cNvGrpSpPr/>
+        <p:nvPr/>
+      </p:nvGrpSpPr>
+      <p:grpSpPr/>
+      <p:sp>
+        <p:nvSpPr>
+          <p:cNvPr id="2" name="Title 1"/>
+          <p:cNvSpPr>
+            <a:spLocks noGrp="1"/>
+          </p:cNvSpPr>
+          <p:nvPr>
+            <p:ph type="title"/>
+          </p:nvPr>
+        </p:nvSpPr>
+        <p:spPr/>
+        <p:txBody>
+          <a:bodyPr/>
+          <a:lstStyle/>
+          <a:p>
+            <a:r>
               <a:t>Future Plans: Path to Lesson 31</a:t>
             </a:r>
           </a:p>
@@ -16258,7 +16485,7 @@
                           </a:solidFill>
                           <a:latin typeface="Quattrocento Sans"/>
                         </a:rPr>
-                        <a:t>Trim table balance; add BALANCE command (reports resting tilt and gravity torque)</a:t>
+                        <a:t>Trim roll balance (weight toward +y); measure hold time with the new DEMO LEVEL test</a:t>
                       </a:r>
                     </a:p>
                   </a:txBody>
@@ -16757,7 +16984,7 @@
 </p:sld>
 </file>
 
-<file path=ppt/slides/slide16.xml><?xml version="1.0" encoding="utf-8"?>
+<file path=ppt/slides/slide17.xml><?xml version="1.0" encoding="utf-8"?>
 <p:sld xmlns:a="http://schemas.openxmlformats.org/drawingml/2006/main" xmlns:p="http://schemas.openxmlformats.org/presentationml/2006/main" xmlns:r="http://schemas.openxmlformats.org/officeDocument/2006/relationships">
   <p:cSld>
     <p:spTree>
@@ -18671,7 +18898,7 @@
               <a:rPr sz="1700" b="0">
                 <a:latin typeface="Quattrocento Sans"/>
               </a:rPr>
-              <a:t>Table balance: pendulous, ≈3° off level</a:t>
+              <a:t>Table balance: pitch fixed, roll still ≈3° off level</a:t>
             </a:r>
           </a:p>
           <a:p>

</xml_diff>

<commit_message>
Re-embed full Quattrocento Sans in prelim deck
The previous save embedded only a subset of the font, which rendered as
scrambled text on machines without Quattrocento Sans installed. Re-saved
with "Embed all characters" so the deck displays correctly everywhere.

Co-Authored-By: Claude Opus 5.5 <noreply@anthropic.com>
</commit_message>
<xml_diff>
--- a/Reports/Astro 331 Lab 8_2_3 Body Problem_Prelim_Pres_FILLED.pptx
+++ b/Reports/Astro 331 Lab 8_2_3 Body Problem_Prelim_Pres_FILLED.pptx
@@ -1,6 +1,6 @@
 
 <file path=ppt/presentation.xml><?xml version="1.0" encoding="utf-8"?>
-<p:presentation xmlns:a="http://schemas.openxmlformats.org/drawingml/2006/main" xmlns:r="http://schemas.openxmlformats.org/officeDocument/2006/relationships" xmlns:p="http://schemas.openxmlformats.org/presentationml/2006/main" showSpecialPlsOnTitleSld="0" strictFirstAndLastChars="0" embedTrueTypeFonts="1" saveSubsetFonts="1" autoCompressPictures="0">
+<p:presentation xmlns:a="http://schemas.openxmlformats.org/drawingml/2006/main" xmlns:r="http://schemas.openxmlformats.org/officeDocument/2006/relationships" xmlns:p="http://schemas.openxmlformats.org/presentationml/2006/main" showSpecialPlsOnTitleSld="0" strictFirstAndLastChars="0" embedTrueTypeFonts="1" autoCompressPictures="0">
   <p:sldMasterIdLst>
     <p:sldMasterId id="2147483648" r:id="rId1"/>
   </p:sldMasterIdLst>
@@ -272,7 +272,7 @@
       <p15:sldGuideLst xmlns:p15="http://schemas.microsoft.com/office/powerpoint/2012/main"/>
     </p:ext>
     <p:ext uri="GoogleSlidesCustomDataVersion2">
-      <go:slidesCustomData xmlns="" xmlns:mc="http://schemas.openxmlformats.org/markup-compatibility/2006" xmlns:mv="urn:schemas-microsoft-com:mac:vml" xmlns:c="http://schemas.openxmlformats.org/drawingml/2006/chart" xmlns:dgm="http://schemas.openxmlformats.org/drawingml/2006/diagram" xmlns:o="urn:schemas-microsoft-com:office:office" xmlns:v="urn:schemas-microsoft-com:vml" xmlns:pvml="urn:schemas-microsoft-com:office:powerpoint" xmlns:com="http://schemas.openxmlformats.org/drawingml/2006/compatibility" xmlns:p14="http://schemas.microsoft.com/office/powerpoint/2010/main" xmlns:p15="http://schemas.microsoft.com/office/powerpoint/2012/main" xmlns:ahyp="http://schemas.microsoft.com/office/drawing/2018/hyperlinkcolor" xmlns:go="http://customooxmlschemas.google.com/" r:id="rId25" roundtripDataSignature="AMtx7mjdeCnu8lAzD9+tydpnVE8c63/G3g=="/>
+      <go:slidesCustomData xmlns:go="http://customooxmlschemas.google.com/" xmlns:ahyp="http://schemas.microsoft.com/office/drawing/2018/hyperlinkcolor" xmlns:p15="http://schemas.microsoft.com/office/powerpoint/2012/main" xmlns:p14="http://schemas.microsoft.com/office/powerpoint/2010/main" xmlns:com="http://schemas.openxmlformats.org/drawingml/2006/compatibility" xmlns:pvml="urn:schemas-microsoft-com:office:powerpoint" xmlns:v="urn:schemas-microsoft-com:vml" xmlns:o="urn:schemas-microsoft-com:office:office" xmlns:dgm="http://schemas.openxmlformats.org/drawingml/2006/diagram" xmlns:c="http://schemas.openxmlformats.org/drawingml/2006/chart" xmlns:mv="urn:schemas-microsoft-com:mac:vml" xmlns:mc="http://schemas.openxmlformats.org/markup-compatibility/2006" xmlns="" r:id="rId25" roundtripDataSignature="AMtx7mjdeCnu8lAzD9+tydpnVE8c63/G3g=="/>
     </p:ext>
   </p:extLst>
 </p:presentation>

</xml_diff>

<commit_message>
Caption and lay out photos on prelim slides 7 and 15
Slide 7: Overall View, Battery Holder Detail, Battery Holder CAD.
Slide 15: Setting Up for Spin, Additional Weight Detail.
Pictures aligned at equal height and centred; embedded fonts unchanged.

Co-Authored-By: Claude Opus 5.5 <noreply@anthropic.com>
</commit_message>
<xml_diff>
--- a/Reports/Astro 331 Lab 8_2_3 Body Problem_Prelim_Pres_FILLED.pptx
+++ b/Reports/Astro 331 Lab 8_2_3 Body Problem_Prelim_Pres_FILLED.pptx
@@ -5,7 +5,7 @@
     <p:sldMasterId id="2147483648" r:id="rId1"/>
   </p:sldMasterIdLst>
   <p:notesMasterIdLst>
-    <p:notesMasterId r:id="rId20"/>
+    <p:notesMasterId r:id="rId21"/>
   </p:notesMasterIdLst>
   <p:sldIdLst>
     <p:sldId id="256" r:id="rId2"/>
@@ -23,19 +23,20 @@
     <p:sldId id="269" r:id="rId14"/>
     <p:sldId id="270" r:id="rId15"/>
     <p:sldId id="274" r:id="rId16"/>
-    <p:sldId id="262" r:id="rId17"/>
-    <p:sldId id="271" r:id="rId18"/>
-    <p:sldId id="272" r:id="rId19"/>
+    <p:sldId id="275" r:id="rId17"/>
+    <p:sldId id="262" r:id="rId18"/>
+    <p:sldId id="271" r:id="rId19"/>
+    <p:sldId id="272" r:id="rId20"/>
   </p:sldIdLst>
   <p:sldSz cx="9144000" cy="6858000" type="screen4x3"/>
   <p:notesSz cx="6858000" cy="9144000"/>
   <p:embeddedFontLst>
     <p:embeddedFont>
       <p:font typeface="Quattrocento Sans" panose="020B0502050000020003" pitchFamily="34" charset="0"/>
-      <p:regular r:id="rId21"/>
-      <p:bold r:id="rId22"/>
-      <p:italic r:id="rId23"/>
-      <p:boldItalic r:id="rId24"/>
+      <p:regular r:id="rId22"/>
+      <p:bold r:id="rId23"/>
+      <p:italic r:id="rId24"/>
+      <p:boldItalic r:id="rId25"/>
     </p:embeddedFont>
   </p:embeddedFontLst>
   <p:defaultTextStyle>
@@ -272,7 +273,7 @@
       <p15:sldGuideLst xmlns:p15="http://schemas.microsoft.com/office/powerpoint/2012/main"/>
     </p:ext>
     <p:ext uri="GoogleSlidesCustomDataVersion2">
-      <go:slidesCustomData xmlns:go="http://customooxmlschemas.google.com/" xmlns:ahyp="http://schemas.microsoft.com/office/drawing/2018/hyperlinkcolor" xmlns:p15="http://schemas.microsoft.com/office/powerpoint/2012/main" xmlns:p14="http://schemas.microsoft.com/office/powerpoint/2010/main" xmlns:com="http://schemas.openxmlformats.org/drawingml/2006/compatibility" xmlns:pvml="urn:schemas-microsoft-com:office:powerpoint" xmlns:v="urn:schemas-microsoft-com:vml" xmlns:o="urn:schemas-microsoft-com:office:office" xmlns:dgm="http://schemas.openxmlformats.org/drawingml/2006/diagram" xmlns:c="http://schemas.openxmlformats.org/drawingml/2006/chart" xmlns:mv="urn:schemas-microsoft-com:mac:vml" xmlns:mc="http://schemas.openxmlformats.org/markup-compatibility/2006" xmlns="" r:id="rId25" roundtripDataSignature="AMtx7mjdeCnu8lAzD9+tydpnVE8c63/G3g=="/>
+      <go:slidesCustomData xmlns:go="http://customooxmlschemas.google.com/" xmlns:ahyp="http://schemas.microsoft.com/office/drawing/2018/hyperlinkcolor" xmlns:p15="http://schemas.microsoft.com/office/powerpoint/2012/main" xmlns:p14="http://schemas.microsoft.com/office/powerpoint/2010/main" xmlns:com="http://schemas.openxmlformats.org/drawingml/2006/compatibility" xmlns:pvml="urn:schemas-microsoft-com:office:powerpoint" xmlns:v="urn:schemas-microsoft-com:vml" xmlns:o="urn:schemas-microsoft-com:office:office" xmlns:dgm="http://schemas.openxmlformats.org/drawingml/2006/diagram" xmlns:c="http://schemas.openxmlformats.org/drawingml/2006/chart" xmlns:mv="urn:schemas-microsoft-com:mac:vml" xmlns:mc="http://schemas.openxmlformats.org/markup-compatibility/2006" xmlns="" r:id="rId26" roundtripDataSignature="AMtx7mjdeCnu8lAzD9+tydpnVE8c63/G3g=="/>
     </p:ext>
   </p:extLst>
 </p:presentation>
@@ -16223,7 +16224,7 @@
           <a:p>
             <a:r>
               <a:rPr lang="en-US" dirty="0"/>
-              <a:t>Data: DEMO SPIN Leveling</a:t>
+              <a:t>DEMO SPIN</a:t>
             </a:r>
           </a:p>
         </p:txBody>
@@ -16319,8 +16320,8 @@
         </p:blipFill>
         <p:spPr>
           <a:xfrm>
-            <a:off x="150960" y="996359"/>
-            <a:ext cx="4375404" cy="5833872"/>
+            <a:off x="729233" y="1097280"/>
+            <a:ext cx="3614166" cy="4818888"/>
           </a:xfrm>
           <a:prstGeom prst="rect">
             <a:avLst/>
@@ -16355,14 +16356,84 @@
         </p:blipFill>
         <p:spPr>
           <a:xfrm>
-            <a:off x="5920740" y="905236"/>
-            <a:ext cx="2523759" cy="3365012"/>
+            <a:off x="4800599" y="1097280"/>
+            <a:ext cx="3614166" cy="4818888"/>
           </a:xfrm>
           <a:prstGeom prst="rect">
             <a:avLst/>
           </a:prstGeom>
         </p:spPr>
       </p:pic>
+      <p:sp>
+        <p:nvSpPr>
+          <p:cNvPr id="10" name="Caption: Setting Up for Spin"/>
+          <p:cNvSpPr txBox="1"/>
+          <p:nvPr/>
+        </p:nvSpPr>
+        <p:spPr>
+          <a:xfrm>
+            <a:off x="729233" y="5971032"/>
+            <a:ext cx="3614166" cy="384048"/>
+          </a:xfrm>
+          <a:prstGeom prst="rect">
+            <a:avLst/>
+          </a:prstGeom>
+          <a:noFill/>
+        </p:spPr>
+        <p:txBody>
+          <a:bodyPr wrap="square" lIns="0" tIns="0" rIns="0" bIns="0" anchor="t">
+            <a:spAutoFit/>
+          </a:bodyPr>
+          <a:lstStyle/>
+          <a:p>
+            <a:pPr algn="ctr"/>
+            <a:r>
+              <a:rPr sz="1600">
+                <a:solidFill>
+                  <a:srgbClr val="000000"/>
+                </a:solidFill>
+                <a:latin typeface="Quattrocento Sans"/>
+              </a:rPr>
+              <a:t>Setting Up for Spin</a:t>
+            </a:r>
+          </a:p>
+        </p:txBody>
+      </p:sp>
+      <p:sp>
+        <p:nvSpPr>
+          <p:cNvPr id="11" name="Caption: Additional Weight Detail"/>
+          <p:cNvSpPr txBox="1"/>
+          <p:nvPr/>
+        </p:nvSpPr>
+        <p:spPr>
+          <a:xfrm>
+            <a:off x="4800599" y="5971032"/>
+            <a:ext cx="3614166" cy="384048"/>
+          </a:xfrm>
+          <a:prstGeom prst="rect">
+            <a:avLst/>
+          </a:prstGeom>
+          <a:noFill/>
+        </p:spPr>
+        <p:txBody>
+          <a:bodyPr wrap="square" lIns="0" tIns="0" rIns="0" bIns="0" anchor="t">
+            <a:spAutoFit/>
+          </a:bodyPr>
+          <a:lstStyle/>
+          <a:p>
+            <a:pPr algn="ctr"/>
+            <a:r>
+              <a:rPr sz="1600">
+                <a:solidFill>
+                  <a:srgbClr val="000000"/>
+                </a:solidFill>
+                <a:latin typeface="Quattrocento Sans"/>
+              </a:rPr>
+              <a:t>Additional Weight Detail</a:t>
+            </a:r>
+          </a:p>
+        </p:txBody>
+      </p:sp>
     </p:spTree>
     <p:extLst>
       <p:ext uri="{BB962C8B-B14F-4D97-AF65-F5344CB8AC3E}">
@@ -16377,6 +16448,300 @@
 </file>
 
 <file path=ppt/slides/slide16.xml><?xml version="1.0" encoding="utf-8"?>
+<p:sld xmlns:a="http://schemas.openxmlformats.org/drawingml/2006/main" xmlns:r="http://schemas.openxmlformats.org/officeDocument/2006/relationships" xmlns:p="http://schemas.openxmlformats.org/presentationml/2006/main">
+  <p:cSld>
+    <p:spTree>
+      <p:nvGrpSpPr>
+        <p:cNvPr id="1" name=""/>
+        <p:cNvGrpSpPr/>
+        <p:nvPr/>
+      </p:nvGrpSpPr>
+      <p:grpSpPr>
+        <a:xfrm>
+          <a:off x="0" y="0"/>
+          <a:ext cx="0" cy="0"/>
+          <a:chOff x="0" y="0"/>
+          <a:chExt cx="0" cy="0"/>
+        </a:xfrm>
+      </p:grpSpPr>
+      <p:sp>
+        <p:nvSpPr>
+          <p:cNvPr id="2" name="Title 1">
+            <a:extLst>
+              <a:ext uri="{FF2B5EF4-FFF2-40B4-BE49-F238E27FC236}">
+                <a16:creationId xmlns:a16="http://schemas.microsoft.com/office/drawing/2014/main" id="{9097644F-4DEA-4B4A-8AB4-4070082412F4}"/>
+              </a:ext>
+            </a:extLst>
+          </p:cNvPr>
+          <p:cNvSpPr>
+            <a:spLocks noGrp="1"/>
+          </p:cNvSpPr>
+          <p:nvPr>
+            <p:ph type="title"/>
+          </p:nvPr>
+        </p:nvSpPr>
+        <p:spPr/>
+        <p:txBody>
+          <a:bodyPr/>
+          <a:lstStyle/>
+          <a:p>
+            <a:r>
+              <a:rPr lang="en-US" dirty="0"/>
+              <a:t>DEMO SPIN: Leveling Video</a:t>
+            </a:r>
+          </a:p>
+        </p:txBody>
+      </p:sp>
+      <p:sp>
+        <p:nvSpPr>
+          <p:cNvPr id="3" name="Text Placeholder 2">
+            <a:extLst>
+              <a:ext uri="{FF2B5EF4-FFF2-40B4-BE49-F238E27FC236}">
+                <a16:creationId xmlns:a16="http://schemas.microsoft.com/office/drawing/2014/main" id="{F3C51A14-DCC9-4D2E-8E8C-050F45D47238}"/>
+              </a:ext>
+            </a:extLst>
+          </p:cNvPr>
+          <p:cNvSpPr>
+            <a:spLocks noGrp="1"/>
+          </p:cNvSpPr>
+          <p:nvPr>
+            <p:ph type="body" idx="1"/>
+          </p:nvPr>
+        </p:nvSpPr>
+        <p:spPr/>
+        <p:txBody>
+          <a:bodyPr/>
+          <a:lstStyle/>
+          <a:p>
+            <a:endParaRPr lang="en-US"/>
+          </a:p>
+        </p:txBody>
+      </p:sp>
+      <p:sp>
+        <p:nvSpPr>
+          <p:cNvPr id="4" name="Slide Number Placeholder 3">
+            <a:extLst>
+              <a:ext uri="{FF2B5EF4-FFF2-40B4-BE49-F238E27FC236}">
+                <a16:creationId xmlns:a16="http://schemas.microsoft.com/office/drawing/2014/main" id="{C0F099E3-E8D6-61AE-7166-798CAC1E286C}"/>
+              </a:ext>
+            </a:extLst>
+          </p:cNvPr>
+          <p:cNvSpPr>
+            <a:spLocks noGrp="1"/>
+          </p:cNvSpPr>
+          <p:nvPr>
+            <p:ph type="sldNum" idx="12"/>
+          </p:nvPr>
+        </p:nvSpPr>
+        <p:spPr/>
+        <p:txBody>
+          <a:bodyPr/>
+          <a:lstStyle/>
+          <a:p>
+            <a:pPr marL="0" lvl="0" indent="0" algn="r" rtl="0">
+              <a:spcBef>
+                <a:spcPts val="0"/>
+              </a:spcBef>
+              <a:spcAft>
+                <a:spcPts val="0"/>
+              </a:spcAft>
+              <a:buNone/>
+            </a:pPr>
+            <a:fld id="{00000000-1234-1234-1234-123412341234}" type="slidenum">
+              <a:rPr lang="en-US" smtClean="0"/>
+              <a:t>16</a:t>
+            </a:fld>
+            <a:endParaRPr lang="en-US"/>
+          </a:p>
+        </p:txBody>
+      </p:sp>
+      <p:pic>
+        <p:nvPicPr>
+          <p:cNvPr id="5" name="LevelTest21Oct">
+            <a:hlinkClick r:id="" action="ppaction://media"/>
+            <a:extLst>
+              <a:ext uri="{FF2B5EF4-FFF2-40B4-BE49-F238E27FC236}">
+                <a16:creationId xmlns:a16="http://schemas.microsoft.com/office/drawing/2014/main" id="{20ABE29E-2AB7-C42D-00A0-F1585378EEBA}"/>
+              </a:ext>
+            </a:extLst>
+          </p:cNvPr>
+          <p:cNvPicPr>
+            <a:picLocks noChangeAspect="1"/>
+          </p:cNvPicPr>
+          <p:nvPr>
+            <a:videoFile r:link="rId2"/>
+            <p:extLst>
+              <p:ext uri="{DAA4B4D4-6D71-4841-9C94-3DE7FCFB9230}">
+                <p14:media xmlns:p14="http://schemas.microsoft.com/office/powerpoint/2010/main" r:embed="rId1"/>
+              </p:ext>
+            </p:extLst>
+          </p:nvPr>
+        </p:nvPicPr>
+        <p:blipFill>
+          <a:blip r:embed="rId4"/>
+          <a:stretch>
+            <a:fillRect/>
+          </a:stretch>
+        </p:blipFill>
+        <p:spPr>
+          <a:xfrm>
+            <a:off x="2976372" y="1002506"/>
+            <a:ext cx="2982277" cy="5301826"/>
+          </a:xfrm>
+          <a:prstGeom prst="rect">
+            <a:avLst/>
+          </a:prstGeom>
+        </p:spPr>
+      </p:pic>
+    </p:spTree>
+    <p:extLst>
+      <p:ext uri="{BB962C8B-B14F-4D97-AF65-F5344CB8AC3E}">
+        <p14:creationId xmlns:p14="http://schemas.microsoft.com/office/powerpoint/2010/main" val="2321664035"/>
+      </p:ext>
+    </p:extLst>
+  </p:cSld>
+  <p:clrMapOvr>
+    <a:masterClrMapping/>
+  </p:clrMapOvr>
+  <p:timing>
+    <p:tnLst>
+      <p:par>
+        <p:cTn id="1" dur="indefinite" restart="never" nodeType="tmRoot">
+          <p:childTnLst>
+            <p:seq concurrent="1" nextAc="seek">
+              <p:cTn id="2" dur="indefinite" nodeType="mainSeq">
+                <p:childTnLst>
+                  <p:par>
+                    <p:cTn id="3" fill="hold">
+                      <p:stCondLst>
+                        <p:cond delay="indefinite"/>
+                      </p:stCondLst>
+                      <p:childTnLst>
+                        <p:par>
+                          <p:cTn id="4" fill="hold">
+                            <p:stCondLst>
+                              <p:cond delay="0"/>
+                            </p:stCondLst>
+                            <p:childTnLst>
+                              <p:par>
+                                <p:cTn id="5" presetID="1" presetClass="mediacall" presetSubtype="0" fill="hold" nodeType="clickEffect">
+                                  <p:stCondLst>
+                                    <p:cond delay="0"/>
+                                  </p:stCondLst>
+                                  <p:childTnLst>
+                                    <p:cmd type="call" cmd="playFrom(0.0)">
+                                      <p:cBhvr>
+                                        <p:cTn id="6" dur="5572" fill="hold"/>
+                                        <p:tgtEl>
+                                          <p:spTgt spid="5"/>
+                                        </p:tgtEl>
+                                      </p:cBhvr>
+                                    </p:cmd>
+                                  </p:childTnLst>
+                                </p:cTn>
+                              </p:par>
+                            </p:childTnLst>
+                          </p:cTn>
+                        </p:par>
+                      </p:childTnLst>
+                    </p:cTn>
+                  </p:par>
+                </p:childTnLst>
+              </p:cTn>
+              <p:prevCondLst>
+                <p:cond evt="onPrev" delay="0">
+                  <p:tgtEl>
+                    <p:sldTgt/>
+                  </p:tgtEl>
+                </p:cond>
+              </p:prevCondLst>
+              <p:nextCondLst>
+                <p:cond evt="onNext" delay="0">
+                  <p:tgtEl>
+                    <p:sldTgt/>
+                  </p:tgtEl>
+                </p:cond>
+              </p:nextCondLst>
+            </p:seq>
+            <p:video>
+              <p:cMediaNode vol="80000">
+                <p:cTn id="7" fill="hold" display="0">
+                  <p:stCondLst>
+                    <p:cond delay="indefinite"/>
+                  </p:stCondLst>
+                </p:cTn>
+                <p:tgtEl>
+                  <p:spTgt spid="5"/>
+                </p:tgtEl>
+              </p:cMediaNode>
+            </p:video>
+            <p:seq concurrent="1" nextAc="seek">
+              <p:cTn id="8" restart="whenNotActive" fill="hold" evtFilter="cancelBubble" nodeType="interactiveSeq">
+                <p:stCondLst>
+                  <p:cond evt="onClick" delay="0">
+                    <p:tgtEl>
+                      <p:spTgt spid="5"/>
+                    </p:tgtEl>
+                  </p:cond>
+                </p:stCondLst>
+                <p:endSync evt="end" delay="0">
+                  <p:rtn val="all"/>
+                </p:endSync>
+                <p:childTnLst>
+                  <p:par>
+                    <p:cTn id="9" fill="hold">
+                      <p:stCondLst>
+                        <p:cond delay="0"/>
+                      </p:stCondLst>
+                      <p:childTnLst>
+                        <p:par>
+                          <p:cTn id="10" fill="hold">
+                            <p:stCondLst>
+                              <p:cond delay="0"/>
+                            </p:stCondLst>
+                            <p:childTnLst>
+                              <p:par>
+                                <p:cTn id="11" presetID="2" presetClass="mediacall" presetSubtype="0" fill="hold" nodeType="clickEffect">
+                                  <p:stCondLst>
+                                    <p:cond delay="0"/>
+                                  </p:stCondLst>
+                                  <p:childTnLst>
+                                    <p:cmd type="call" cmd="togglePause">
+                                      <p:cBhvr>
+                                        <p:cTn id="12" dur="1" fill="hold"/>
+                                        <p:tgtEl>
+                                          <p:spTgt spid="5"/>
+                                        </p:tgtEl>
+                                      </p:cBhvr>
+                                    </p:cmd>
+                                  </p:childTnLst>
+                                </p:cTn>
+                              </p:par>
+                            </p:childTnLst>
+                          </p:cTn>
+                        </p:par>
+                      </p:childTnLst>
+                    </p:cTn>
+                  </p:par>
+                </p:childTnLst>
+              </p:cTn>
+              <p:nextCondLst>
+                <p:cond evt="onClick" delay="0">
+                  <p:tgtEl>
+                    <p:spTgt spid="5"/>
+                  </p:tgtEl>
+                </p:cond>
+              </p:nextCondLst>
+            </p:seq>
+          </p:childTnLst>
+        </p:cTn>
+      </p:par>
+    </p:tnLst>
+  </p:timing>
+</p:sld>
+</file>
+
+<file path=ppt/slides/slide17.xml><?xml version="1.0" encoding="utf-8"?>
 <p:sld xmlns:a="http://schemas.openxmlformats.org/drawingml/2006/main" xmlns:r="http://schemas.openxmlformats.org/officeDocument/2006/relationships" xmlns:p="http://schemas.openxmlformats.org/presentationml/2006/main">
   <p:cSld>
     <p:spTree>
@@ -16491,7 +16856,7 @@
             </a:pPr>
             <a:fld id="{00000000-1234-1234-1234-123412341234}" type="slidenum">
               <a:rPr lang="en-US"/>
-              <a:t>16</a:t>
+              <a:t>17</a:t>
             </a:fld>
             <a:endParaRPr/>
           </a:p>
@@ -16751,7 +17116,7 @@
         <p:spPr>
           <a:xfrm>
             <a:off x="3182112" y="1508760"/>
-            <a:ext cx="2743200" cy="4343400"/>
+            <a:ext cx="2743200" cy="3398366"/>
           </a:xfrm>
           <a:prstGeom prst="rect">
             <a:avLst/>
@@ -16813,7 +17178,7 @@
               <a:rPr sz="1700" b="0" dirty="0">
                 <a:latin typeface="Quattrocento Sans"/>
               </a:rPr>
-              <a:t>Wheel A rub / pack; wheel C oscillation</a:t>
+              <a:t>Wheel A rub; wheel C oscillation</a:t>
             </a:r>
           </a:p>
           <a:p>
@@ -16847,17 +17212,8 @@
               <a:rPr sz="1700" b="0" dirty="0">
                 <a:latin typeface="Quattrocento Sans"/>
               </a:rPr>
-              <a:t>Real inertia (fits 0.05–0.13 kg·m²</a:t>
-            </a:r>
-            <a:r>
-              <a:rPr lang="en-US" sz="1700" b="0" dirty="0">
-                <a:latin typeface="Quattrocento Sans"/>
-              </a:rPr>
-              <a:t>)</a:t>
-            </a:r>
-            <a:endParaRPr sz="1700" b="0" dirty="0">
-              <a:latin typeface="Quattrocento Sans"/>
-            </a:endParaRPr>
+              <a:t>Real inertia</a:t>
+            </a:r>
           </a:p>
         </p:txBody>
       </p:sp>
@@ -17063,7 +17419,7 @@
 </p:sld>
 </file>
 
-<file path=ppt/slides/slide17.xml><?xml version="1.0" encoding="utf-8"?>
+<file path=ppt/slides/slide18.xml><?xml version="1.0" encoding="utf-8"?>
 <p:sld xmlns:a="http://schemas.openxmlformats.org/drawingml/2006/main" xmlns:r="http://schemas.openxmlformats.org/officeDocument/2006/relationships" xmlns:p="http://schemas.openxmlformats.org/presentationml/2006/main">
   <p:cSld>
     <p:spTree>
@@ -17145,7 +17501,7 @@
             </a:pPr>
             <a:fld id="{00000000-1234-1234-1234-123412341234}" type="slidenum">
               <a:rPr lang="en-US"/>
-              <a:t>17</a:t>
+              <a:t>18</a:t>
             </a:fld>
             <a:endParaRPr/>
           </a:p>
@@ -18116,7 +18472,7 @@
 </p:sld>
 </file>
 
-<file path=ppt/slides/slide18.xml><?xml version="1.0" encoding="utf-8"?>
+<file path=ppt/slides/slide19.xml><?xml version="1.0" encoding="utf-8"?>
 <p:sld xmlns:a="http://schemas.openxmlformats.org/drawingml/2006/main" xmlns:r="http://schemas.openxmlformats.org/officeDocument/2006/relationships" xmlns:p="http://schemas.openxmlformats.org/presentationml/2006/main">
   <p:cSld>
     <p:spTree>
@@ -18323,7 +18679,7 @@
             </a:pPr>
             <a:fld id="{00000000-1234-1234-1234-123412341234}" type="slidenum">
               <a:rPr lang="en-US"/>
-              <a:t>18</a:t>
+              <a:t>19</a:t>
             </a:fld>
             <a:endParaRPr/>
           </a:p>
@@ -20048,7 +20404,19 @@
               <a:rPr sz="1500" b="0" dirty="0">
                 <a:latin typeface="Quattrocento Sans"/>
               </a:rPr>
-              <a:t>Power system: separate logic pack + 5 V boost (verified 5.09 V), one 12 V pack per wheel, low-side motor switch, star ground, bench wiring sheet</a:t>
+              <a:t>Power system: separate </a:t>
+            </a:r>
+            <a:r>
+              <a:rPr lang="en-US" sz="1500" b="0" dirty="0">
+                <a:latin typeface="Quattrocento Sans"/>
+              </a:rPr>
+              <a:t>5V </a:t>
+            </a:r>
+            <a:r>
+              <a:rPr sz="1500" b="0" dirty="0">
+                <a:latin typeface="Quattrocento Sans"/>
+              </a:rPr>
+              <a:t>logic pack, one 12 V pack per wheel, low-side motor switch, star ground, bench wiring sheet</a:t>
             </a:r>
           </a:p>
           <a:p>
@@ -20240,8 +20608,8 @@
         </p:blipFill>
         <p:spPr>
           <a:xfrm>
-            <a:off x="5270872" y="1257130"/>
-            <a:ext cx="3538728" cy="4718304"/>
+            <a:off x="274319" y="1791372"/>
+            <a:ext cx="2573028" cy="3430703"/>
           </a:xfrm>
           <a:prstGeom prst="rect">
             <a:avLst/>
@@ -20276,8 +20644,8 @@
         </p:blipFill>
         <p:spPr>
           <a:xfrm>
-            <a:off x="200025" y="930513"/>
-            <a:ext cx="3974660" cy="5299546"/>
+            <a:off x="3121668" y="1791372"/>
+            <a:ext cx="2573028" cy="3430703"/>
           </a:xfrm>
           <a:prstGeom prst="rect">
             <a:avLst/>
@@ -20306,14 +20674,119 @@
         </p:blipFill>
         <p:spPr>
           <a:xfrm>
-            <a:off x="3141547" y="1558829"/>
-            <a:ext cx="3162463" cy="3740342"/>
+            <a:off x="5969016" y="1791372"/>
+            <a:ext cx="2900663" cy="3430703"/>
           </a:xfrm>
           <a:prstGeom prst="rect">
             <a:avLst/>
           </a:prstGeom>
         </p:spPr>
       </p:pic>
+      <p:sp>
+        <p:nvSpPr>
+          <p:cNvPr id="15" name="Caption: Overall View"/>
+          <p:cNvSpPr txBox="1"/>
+          <p:nvPr/>
+        </p:nvSpPr>
+        <p:spPr>
+          <a:xfrm>
+            <a:off x="274319" y="5276939"/>
+            <a:ext cx="2573028" cy="384048"/>
+          </a:xfrm>
+          <a:prstGeom prst="rect">
+            <a:avLst/>
+          </a:prstGeom>
+          <a:noFill/>
+        </p:spPr>
+        <p:txBody>
+          <a:bodyPr wrap="square" lIns="0" tIns="0" rIns="0" bIns="0" anchor="t">
+            <a:spAutoFit/>
+          </a:bodyPr>
+          <a:lstStyle/>
+          <a:p>
+            <a:pPr algn="ctr"/>
+            <a:r>
+              <a:rPr sz="1600">
+                <a:solidFill>
+                  <a:srgbClr val="000000"/>
+                </a:solidFill>
+                <a:latin typeface="Quattrocento Sans"/>
+              </a:rPr>
+              <a:t>Overall View</a:t>
+            </a:r>
+          </a:p>
+        </p:txBody>
+      </p:sp>
+      <p:sp>
+        <p:nvSpPr>
+          <p:cNvPr id="16" name="Caption: Battery Holder Detail"/>
+          <p:cNvSpPr txBox="1"/>
+          <p:nvPr/>
+        </p:nvSpPr>
+        <p:spPr>
+          <a:xfrm>
+            <a:off x="3121668" y="5276939"/>
+            <a:ext cx="2573028" cy="384048"/>
+          </a:xfrm>
+          <a:prstGeom prst="rect">
+            <a:avLst/>
+          </a:prstGeom>
+          <a:noFill/>
+        </p:spPr>
+        <p:txBody>
+          <a:bodyPr wrap="square" lIns="0" tIns="0" rIns="0" bIns="0" anchor="t">
+            <a:spAutoFit/>
+          </a:bodyPr>
+          <a:lstStyle/>
+          <a:p>
+            <a:pPr algn="ctr"/>
+            <a:r>
+              <a:rPr sz="1600">
+                <a:solidFill>
+                  <a:srgbClr val="000000"/>
+                </a:solidFill>
+                <a:latin typeface="Quattrocento Sans"/>
+              </a:rPr>
+              <a:t>Battery Holder Detail</a:t>
+            </a:r>
+          </a:p>
+        </p:txBody>
+      </p:sp>
+      <p:sp>
+        <p:nvSpPr>
+          <p:cNvPr id="17" name="Caption: Battery Holder CAD"/>
+          <p:cNvSpPr txBox="1"/>
+          <p:nvPr/>
+        </p:nvSpPr>
+        <p:spPr>
+          <a:xfrm>
+            <a:off x="5969016" y="5276939"/>
+            <a:ext cx="2900663" cy="384048"/>
+          </a:xfrm>
+          <a:prstGeom prst="rect">
+            <a:avLst/>
+          </a:prstGeom>
+          <a:noFill/>
+        </p:spPr>
+        <p:txBody>
+          <a:bodyPr wrap="square" lIns="0" tIns="0" rIns="0" bIns="0" anchor="t">
+            <a:spAutoFit/>
+          </a:bodyPr>
+          <a:lstStyle/>
+          <a:p>
+            <a:pPr algn="ctr"/>
+            <a:r>
+              <a:rPr sz="1600">
+                <a:solidFill>
+                  <a:srgbClr val="000000"/>
+                </a:solidFill>
+                <a:latin typeface="Quattrocento Sans"/>
+              </a:rPr>
+              <a:t>Battery Holder CAD</a:t>
+            </a:r>
+          </a:p>
+        </p:txBody>
+      </p:sp>
     </p:spTree>
     <p:extLst>
       <p:ext uri="{BB962C8B-B14F-4D97-AF65-F5344CB8AC3E}">
@@ -21617,7 +22090,19 @@
               <a:rPr sz="1500" b="0" dirty="0">
                 <a:latin typeface="Quattrocento Sans"/>
               </a:rPr>
-              <a:t>Same gains on every wheel, so A/C differences are hardware: A rubs and its pack is ≈1 V low; C is still unexplained. The start delay is static friction.</a:t>
+              <a:t>Same gains on every wheel, so A/C differences are hardware: A rub</a:t>
+            </a:r>
+            <a:r>
+              <a:rPr lang="en-US" sz="1500" b="0" dirty="0">
+                <a:latin typeface="Quattrocento Sans"/>
+              </a:rPr>
+              <a:t>s</a:t>
+            </a:r>
+            <a:r>
+              <a:rPr sz="1500" b="0" dirty="0">
+                <a:latin typeface="Quattrocento Sans"/>
+              </a:rPr>
+              <a:t>; C is still unexplained. The start delay is static friction.</a:t>
             </a:r>
           </a:p>
           <a:p>
@@ -21640,7 +22125,7 @@
               <a:rPr lang="en-US" sz="1500" b="0" dirty="0">
                 <a:latin typeface="Quattrocento Sans"/>
               </a:rPr>
-              <a:t>Fix A’s rub and charge pack A; check C’s pack voltage under load and its encoder; add static-friction compensation. Repeat test.</a:t>
+              <a:t>Fix A’s rub; check C’s pack voltage under load and its encoder; add static-friction compensation. Repeat test.</a:t>
             </a:r>
             <a:endParaRPr sz="1500" b="0" dirty="0">
               <a:latin typeface="Quattrocento Sans"/>

</xml_diff>